<commit_message>
Restyle the content-plan deck to match the dark lime poster.
Titles mix a heavy sans with script, on a dark background, and the PowerPoint file keeps that look.

Co-authored-by: VG676-main <VG676-main@users.noreply.github.com>
</commit_message>
<xml_diff>
--- a/kontent-plan/Контент-план.pptx
+++ b/kontent-plan/Контент-план.pptx
@@ -3092,239 +3092,30 @@
         <p:nvPr/>
       </p:nvGrpSpPr>
       <p:grpSpPr/>
-      <p:sp>
-        <p:nvSpPr>
-          <p:cNvPr id="2" name="Rectangle 1"/>
-          <p:cNvSpPr/>
+      <p:pic>
+        <p:nvPicPr>
+          <p:cNvPr id="2" name="Picture 1" descr="01.png"/>
+          <p:cNvPicPr>
+            <a:picLocks noChangeAspect="1"/>
+          </p:cNvPicPr>
           <p:nvPr/>
-        </p:nvSpPr>
+        </p:nvPicPr>
+        <p:blipFill>
+          <a:blip r:embed="rId2"/>
+          <a:stretch>
+            <a:fillRect/>
+          </a:stretch>
+        </p:blipFill>
         <p:spPr>
           <a:xfrm>
             <a:off x="0" y="0"/>
-            <a:ext cx="12191695" cy="109728"/>
+            <a:ext cx="12191695" cy="6858000"/>
           </a:xfrm>
           <a:prstGeom prst="rect">
             <a:avLst/>
           </a:prstGeom>
-          <a:solidFill>
-            <a:srgbClr val="2E75B6"/>
-          </a:solidFill>
-          <a:ln>
-            <a:noFill/>
-          </a:ln>
         </p:spPr>
-        <p:style>
-          <a:lnRef idx="1">
-            <a:schemeClr val="accent1"/>
-          </a:lnRef>
-          <a:fillRef idx="3">
-            <a:schemeClr val="accent1"/>
-          </a:fillRef>
-          <a:effectRef idx="2">
-            <a:schemeClr val="accent1"/>
-          </a:effectRef>
-          <a:fontRef idx="minor">
-            <a:schemeClr val="lt1"/>
-          </a:fontRef>
-        </p:style>
-        <p:txBody>
-          <a:bodyPr rtlCol="0" anchor="ctr"/>
-          <a:lstStyle/>
-          <a:p>
-            <a:pPr algn="ctr"/>
-          </a:p>
-        </p:txBody>
-      </p:sp>
-      <p:sp>
-        <p:nvSpPr>
-          <p:cNvPr id="3" name="TextBox 2"/>
-          <p:cNvSpPr txBox="1"/>
-          <p:nvPr/>
-        </p:nvSpPr>
-        <p:spPr>
-          <a:xfrm>
-            <a:off x="566928" y="292608"/>
-            <a:ext cx="11064240" cy="713232"/>
-          </a:xfrm>
-          <a:prstGeom prst="rect">
-            <a:avLst/>
-          </a:prstGeom>
-          <a:noFill/>
-        </p:spPr>
-        <p:txBody>
-          <a:bodyPr wrap="square" lIns="18288" rIns="18288" tIns="0" bIns="0" anchor="t"/>
-          <a:lstStyle/>
-          <a:p>
-            <a:pPr algn="l">
-              <a:lnSpc>
-                <a:spcPct val="105000"/>
-              </a:lnSpc>
-              <a:spcAft>
-                <a:spcPts val="0"/>
-              </a:spcAft>
-            </a:pPr>
-            <a:r>
-              <a:rPr sz="3200" b="1" i="0" lang="ru-RU" dirty="0">
-                <a:solidFill>
-                  <a:srgbClr val="1F4E79"/>
-                </a:solidFill>
-                <a:latin typeface="Arial"/>
-                <a:cs typeface="Arial"/>
-                <a:ea typeface="Arial"/>
-              </a:rPr>
-              <a:t>Что такое контент-план?</a:t>
-            </a:r>
-          </a:p>
-        </p:txBody>
-      </p:sp>
-      <p:sp>
-        <p:nvSpPr>
-          <p:cNvPr id="4" name="Rectangle 3"/>
-          <p:cNvSpPr/>
-          <p:nvPr/>
-        </p:nvSpPr>
-        <p:spPr>
-          <a:xfrm>
-            <a:off x="585216" y="1060704"/>
-            <a:ext cx="2834640" cy="32004"/>
-          </a:xfrm>
-          <a:prstGeom prst="rect">
-            <a:avLst/>
-          </a:prstGeom>
-          <a:solidFill>
-            <a:srgbClr val="5B9BD5"/>
-          </a:solidFill>
-          <a:ln>
-            <a:noFill/>
-          </a:ln>
-        </p:spPr>
-        <p:style>
-          <a:lnRef idx="1">
-            <a:schemeClr val="accent1"/>
-          </a:lnRef>
-          <a:fillRef idx="3">
-            <a:schemeClr val="accent1"/>
-          </a:fillRef>
-          <a:effectRef idx="2">
-            <a:schemeClr val="accent1"/>
-          </a:effectRef>
-          <a:fontRef idx="minor">
-            <a:schemeClr val="lt1"/>
-          </a:fontRef>
-        </p:style>
-        <p:txBody>
-          <a:bodyPr rtlCol="0" anchor="ctr"/>
-          <a:lstStyle/>
-          <a:p>
-            <a:pPr algn="ctr"/>
-          </a:p>
-        </p:txBody>
-      </p:sp>
-      <p:sp>
-        <p:nvSpPr>
-          <p:cNvPr id="5" name="TextBox 4"/>
-          <p:cNvSpPr txBox="1"/>
-          <p:nvPr/>
-        </p:nvSpPr>
-        <p:spPr>
-          <a:xfrm>
-            <a:off x="585216" y="1463040"/>
-            <a:ext cx="10972800" cy="4389120"/>
-          </a:xfrm>
-          <a:prstGeom prst="rect">
-            <a:avLst/>
-          </a:prstGeom>
-          <a:noFill/>
-        </p:spPr>
-        <p:txBody>
-          <a:bodyPr wrap="square" lIns="18288" rIns="18288" tIns="0" bIns="0" anchor="t"/>
-          <a:lstStyle/>
-          <a:p>
-            <a:pPr algn="l">
-              <a:lnSpc>
-                <a:spcPct val="115000"/>
-              </a:lnSpc>
-              <a:spcAft>
-                <a:spcPts val="1600"/>
-              </a:spcAft>
-            </a:pPr>
-            <a:r>
-              <a:rPr sz="2200" b="0" i="0" lang="ru-RU" dirty="0">
-                <a:solidFill>
-                  <a:srgbClr val="2D2D2D"/>
-                </a:solidFill>
-                <a:latin typeface="Arial"/>
-                <a:cs typeface="Arial"/>
-                <a:ea typeface="Arial"/>
-              </a:rPr>
-              <a:t>Контент-план — это заранее составленный план публикаций, который определяет, какой материал, когда и где будет опубликован.</a:t>
-            </a:r>
-          </a:p>
-          <a:p>
-            <a:pPr algn="l">
-              <a:lnSpc>
-                <a:spcPct val="115000"/>
-              </a:lnSpc>
-              <a:spcAft>
-                <a:spcPts val="0"/>
-              </a:spcAft>
-            </a:pPr>
-            <a:r>
-              <a:rPr sz="2200" b="0" i="0" lang="ru-RU" dirty="0">
-                <a:solidFill>
-                  <a:srgbClr val="2D2D2D"/>
-                </a:solidFill>
-                <a:latin typeface="Arial"/>
-                <a:cs typeface="Arial"/>
-                <a:ea typeface="Arial"/>
-              </a:rPr>
-              <a:t>В журналистике контент-план помогает организовать работу редакции, распределить темы и заранее подготовить материал.</a:t>
-            </a:r>
-          </a:p>
-        </p:txBody>
-      </p:sp>
-      <p:sp>
-        <p:nvSpPr>
-          <p:cNvPr id="6" name="TextBox 5"/>
-          <p:cNvSpPr txBox="1"/>
-          <p:nvPr/>
-        </p:nvSpPr>
-        <p:spPr>
-          <a:xfrm>
-            <a:off x="10607040" y="6473952"/>
-            <a:ext cx="1097280" cy="292608"/>
-          </a:xfrm>
-          <a:prstGeom prst="rect">
-            <a:avLst/>
-          </a:prstGeom>
-          <a:noFill/>
-        </p:spPr>
-        <p:txBody>
-          <a:bodyPr wrap="square" lIns="18288" rIns="18288" tIns="0" bIns="0" anchor="t"/>
-          <a:lstStyle/>
-          <a:p>
-            <a:pPr algn="r">
-              <a:lnSpc>
-                <a:spcPct val="105000"/>
-              </a:lnSpc>
-              <a:spcAft>
-                <a:spcPts val="0"/>
-              </a:spcAft>
-            </a:pPr>
-            <a:r>
-              <a:rPr sz="1400" b="0" i="0" lang="ru-RU" dirty="0">
-                <a:solidFill>
-                  <a:srgbClr val="555555"/>
-                </a:solidFill>
-                <a:latin typeface="Arial"/>
-                <a:cs typeface="Arial"/>
-                <a:ea typeface="Arial"/>
-              </a:rPr>
-              <a:t>1</a:t>
-            </a:r>
-          </a:p>
-        </p:txBody>
-      </p:sp>
+      </p:pic>
     </p:spTree>
   </p:cSld>
   <p:clrMapOvr>
@@ -3343,575 +3134,30 @@
         <p:nvPr/>
       </p:nvGrpSpPr>
       <p:grpSpPr/>
-      <p:sp>
-        <p:nvSpPr>
-          <p:cNvPr id="2" name="Rectangle 1"/>
-          <p:cNvSpPr/>
+      <p:pic>
+        <p:nvPicPr>
+          <p:cNvPr id="2" name="Picture 1" descr="02.png"/>
+          <p:cNvPicPr>
+            <a:picLocks noChangeAspect="1"/>
+          </p:cNvPicPr>
           <p:nvPr/>
-        </p:nvSpPr>
+        </p:nvPicPr>
+        <p:blipFill>
+          <a:blip r:embed="rId2"/>
+          <a:stretch>
+            <a:fillRect/>
+          </a:stretch>
+        </p:blipFill>
         <p:spPr>
           <a:xfrm>
             <a:off x="0" y="0"/>
-            <a:ext cx="12191695" cy="109728"/>
+            <a:ext cx="12191695" cy="6858000"/>
           </a:xfrm>
           <a:prstGeom prst="rect">
             <a:avLst/>
           </a:prstGeom>
-          <a:solidFill>
-            <a:srgbClr val="2E75B6"/>
-          </a:solidFill>
-          <a:ln>
-            <a:noFill/>
-          </a:ln>
         </p:spPr>
-        <p:style>
-          <a:lnRef idx="1">
-            <a:schemeClr val="accent1"/>
-          </a:lnRef>
-          <a:fillRef idx="3">
-            <a:schemeClr val="accent1"/>
-          </a:fillRef>
-          <a:effectRef idx="2">
-            <a:schemeClr val="accent1"/>
-          </a:effectRef>
-          <a:fontRef idx="minor">
-            <a:schemeClr val="lt1"/>
-          </a:fontRef>
-        </p:style>
-        <p:txBody>
-          <a:bodyPr rtlCol="0" anchor="ctr"/>
-          <a:lstStyle/>
-          <a:p>
-            <a:pPr algn="ctr"/>
-          </a:p>
-        </p:txBody>
-      </p:sp>
-      <p:sp>
-        <p:nvSpPr>
-          <p:cNvPr id="3" name="TextBox 2"/>
-          <p:cNvSpPr txBox="1"/>
-          <p:nvPr/>
-        </p:nvSpPr>
-        <p:spPr>
-          <a:xfrm>
-            <a:off x="566928" y="292608"/>
-            <a:ext cx="11064240" cy="713232"/>
-          </a:xfrm>
-          <a:prstGeom prst="rect">
-            <a:avLst/>
-          </a:prstGeom>
-          <a:noFill/>
-        </p:spPr>
-        <p:txBody>
-          <a:bodyPr wrap="square" lIns="18288" rIns="18288" tIns="0" bIns="0" anchor="t"/>
-          <a:lstStyle/>
-          <a:p>
-            <a:pPr algn="l">
-              <a:lnSpc>
-                <a:spcPct val="105000"/>
-              </a:lnSpc>
-              <a:spcAft>
-                <a:spcPts val="0"/>
-              </a:spcAft>
-            </a:pPr>
-            <a:r>
-              <a:rPr sz="3200" b="1" i="0" lang="ru-RU" dirty="0">
-                <a:solidFill>
-                  <a:srgbClr val="1F4E79"/>
-                </a:solidFill>
-                <a:latin typeface="Arial"/>
-                <a:cs typeface="Arial"/>
-                <a:ea typeface="Arial"/>
-              </a:rPr>
-              <a:t>Как составить контент-план?</a:t>
-            </a:r>
-          </a:p>
-        </p:txBody>
-      </p:sp>
-      <p:sp>
-        <p:nvSpPr>
-          <p:cNvPr id="4" name="Rectangle 3"/>
-          <p:cNvSpPr/>
-          <p:nvPr/>
-        </p:nvSpPr>
-        <p:spPr>
-          <a:xfrm>
-            <a:off x="585216" y="1060704"/>
-            <a:ext cx="2834640" cy="32004"/>
-          </a:xfrm>
-          <a:prstGeom prst="rect">
-            <a:avLst/>
-          </a:prstGeom>
-          <a:solidFill>
-            <a:srgbClr val="5B9BD5"/>
-          </a:solidFill>
-          <a:ln>
-            <a:noFill/>
-          </a:ln>
-        </p:spPr>
-        <p:style>
-          <a:lnRef idx="1">
-            <a:schemeClr val="accent1"/>
-          </a:lnRef>
-          <a:fillRef idx="3">
-            <a:schemeClr val="accent1"/>
-          </a:fillRef>
-          <a:effectRef idx="2">
-            <a:schemeClr val="accent1"/>
-          </a:effectRef>
-          <a:fontRef idx="minor">
-            <a:schemeClr val="lt1"/>
-          </a:fontRef>
-        </p:style>
-        <p:txBody>
-          <a:bodyPr rtlCol="0" anchor="ctr"/>
-          <a:lstStyle/>
-          <a:p>
-            <a:pPr algn="ctr"/>
-          </a:p>
-        </p:txBody>
-      </p:sp>
-      <p:sp>
-        <p:nvSpPr>
-          <p:cNvPr id="5" name="TextBox 4"/>
-          <p:cNvSpPr txBox="1"/>
-          <p:nvPr/>
-        </p:nvSpPr>
-        <p:spPr>
-          <a:xfrm>
-            <a:off x="585216" y="1261872"/>
-            <a:ext cx="10972800" cy="365760"/>
-          </a:xfrm>
-          <a:prstGeom prst="rect">
-            <a:avLst/>
-          </a:prstGeom>
-          <a:noFill/>
-        </p:spPr>
-        <p:txBody>
-          <a:bodyPr wrap="square" lIns="18288" rIns="18288" tIns="0" bIns="0" anchor="t"/>
-          <a:lstStyle/>
-          <a:p>
-            <a:pPr algn="l">
-              <a:lnSpc>
-                <a:spcPct val="105000"/>
-              </a:lnSpc>
-              <a:spcAft>
-                <a:spcPts val="0"/>
-              </a:spcAft>
-            </a:pPr>
-            <a:r>
-              <a:rPr sz="1800" b="0" i="0" lang="ru-RU" dirty="0">
-                <a:solidFill>
-                  <a:srgbClr val="555555"/>
-                </a:solidFill>
-                <a:latin typeface="Arial"/>
-                <a:cs typeface="Arial"/>
-                <a:ea typeface="Arial"/>
-              </a:rPr>
-              <a:t>Разработка контент-плана может проходить в несколько этапов:</a:t>
-            </a:r>
-          </a:p>
-        </p:txBody>
-      </p:sp>
-      <p:sp>
-        <p:nvSpPr>
-          <p:cNvPr id="6" name="TextBox 5"/>
-          <p:cNvSpPr txBox="1"/>
-          <p:nvPr/>
-        </p:nvSpPr>
-        <p:spPr>
-          <a:xfrm>
-            <a:off x="585216" y="1783080"/>
-            <a:ext cx="5394960" cy="1371600"/>
-          </a:xfrm>
-          <a:prstGeom prst="rect">
-            <a:avLst/>
-          </a:prstGeom>
-          <a:noFill/>
-        </p:spPr>
-        <p:txBody>
-          <a:bodyPr wrap="square" lIns="18288" rIns="18288" tIns="0" bIns="0" anchor="t"/>
-          <a:lstStyle/>
-          <a:p>
-            <a:pPr algn="l">
-              <a:lnSpc>
-                <a:spcPct val="105000"/>
-              </a:lnSpc>
-              <a:spcAft>
-                <a:spcPts val="200"/>
-              </a:spcAft>
-            </a:pPr>
-            <a:r>
-              <a:rPr sz="2000" b="1" i="0" lang="ru-RU" dirty="0">
-                <a:solidFill>
-                  <a:srgbClr val="1F4E79"/>
-                </a:solidFill>
-                <a:latin typeface="Arial"/>
-                <a:cs typeface="Arial"/>
-                <a:ea typeface="Arial"/>
-              </a:rPr>
-              <a:t>1. Определить цель.</a:t>
-            </a:r>
-          </a:p>
-          <a:p>
-            <a:pPr algn="l">
-              <a:lnSpc>
-                <a:spcPct val="105000"/>
-              </a:lnSpc>
-              <a:spcAft>
-                <a:spcPts val="0"/>
-              </a:spcAft>
-            </a:pPr>
-            <a:r>
-              <a:rPr sz="1600" b="0" i="0" lang="ru-RU" dirty="0">
-                <a:solidFill>
-                  <a:srgbClr val="2D2D2D"/>
-                </a:solidFill>
-                <a:latin typeface="Arial"/>
-                <a:cs typeface="Arial"/>
-                <a:ea typeface="Arial"/>
-              </a:rPr>
-              <a:t>Нужно понять, какую информацию мы хотим донести до аудитории.</a:t>
-            </a:r>
-          </a:p>
-        </p:txBody>
-      </p:sp>
-      <p:sp>
-        <p:nvSpPr>
-          <p:cNvPr id="7" name="TextBox 6"/>
-          <p:cNvSpPr txBox="1"/>
-          <p:nvPr/>
-        </p:nvSpPr>
-        <p:spPr>
-          <a:xfrm>
-            <a:off x="585216" y="3291839"/>
-            <a:ext cx="5394960" cy="1371600"/>
-          </a:xfrm>
-          <a:prstGeom prst="rect">
-            <a:avLst/>
-          </a:prstGeom>
-          <a:noFill/>
-        </p:spPr>
-        <p:txBody>
-          <a:bodyPr wrap="square" lIns="18288" rIns="18288" tIns="0" bIns="0" anchor="t"/>
-          <a:lstStyle/>
-          <a:p>
-            <a:pPr algn="l">
-              <a:lnSpc>
-                <a:spcPct val="105000"/>
-              </a:lnSpc>
-              <a:spcAft>
-                <a:spcPts val="200"/>
-              </a:spcAft>
-            </a:pPr>
-            <a:r>
-              <a:rPr sz="2000" b="1" i="0" lang="ru-RU" dirty="0">
-                <a:solidFill>
-                  <a:srgbClr val="1F4E79"/>
-                </a:solidFill>
-                <a:latin typeface="Arial"/>
-                <a:cs typeface="Arial"/>
-                <a:ea typeface="Arial"/>
-              </a:rPr>
-              <a:t>2. Изучить аудиторию.</a:t>
-            </a:r>
-          </a:p>
-          <a:p>
-            <a:pPr algn="l">
-              <a:lnSpc>
-                <a:spcPct val="105000"/>
-              </a:lnSpc>
-              <a:spcAft>
-                <a:spcPts val="0"/>
-              </a:spcAft>
-            </a:pPr>
-            <a:r>
-              <a:rPr sz="1600" b="0" i="0" lang="ru-RU" dirty="0">
-                <a:solidFill>
-                  <a:srgbClr val="2D2D2D"/>
-                </a:solidFill>
-                <a:latin typeface="Arial"/>
-                <a:cs typeface="Arial"/>
-                <a:ea typeface="Arial"/>
-              </a:rPr>
-              <a:t>Надо определить её интересы и информационные потребности.</a:t>
-            </a:r>
-          </a:p>
-        </p:txBody>
-      </p:sp>
-      <p:sp>
-        <p:nvSpPr>
-          <p:cNvPr id="8" name="TextBox 7"/>
-          <p:cNvSpPr txBox="1"/>
-          <p:nvPr/>
-        </p:nvSpPr>
-        <p:spPr>
-          <a:xfrm>
-            <a:off x="585216" y="4800600"/>
-            <a:ext cx="5394960" cy="1371600"/>
-          </a:xfrm>
-          <a:prstGeom prst="rect">
-            <a:avLst/>
-          </a:prstGeom>
-          <a:noFill/>
-        </p:spPr>
-        <p:txBody>
-          <a:bodyPr wrap="square" lIns="18288" rIns="18288" tIns="0" bIns="0" anchor="t"/>
-          <a:lstStyle/>
-          <a:p>
-            <a:pPr algn="l">
-              <a:lnSpc>
-                <a:spcPct val="105000"/>
-              </a:lnSpc>
-              <a:spcAft>
-                <a:spcPts val="200"/>
-              </a:spcAft>
-            </a:pPr>
-            <a:r>
-              <a:rPr sz="2000" b="1" i="0" lang="ru-RU" dirty="0">
-                <a:solidFill>
-                  <a:srgbClr val="1F4E79"/>
-                </a:solidFill>
-                <a:latin typeface="Arial"/>
-                <a:cs typeface="Arial"/>
-                <a:ea typeface="Arial"/>
-              </a:rPr>
-              <a:t>3. Составить список тем.</a:t>
-            </a:r>
-          </a:p>
-          <a:p>
-            <a:pPr algn="l">
-              <a:lnSpc>
-                <a:spcPct val="105000"/>
-              </a:lnSpc>
-              <a:spcAft>
-                <a:spcPts val="0"/>
-              </a:spcAft>
-            </a:pPr>
-            <a:r>
-              <a:rPr sz="1600" b="0" i="0" lang="ru-RU" dirty="0">
-                <a:solidFill>
-                  <a:srgbClr val="2D2D2D"/>
-                </a:solidFill>
-                <a:latin typeface="Arial"/>
-                <a:cs typeface="Arial"/>
-                <a:ea typeface="Arial"/>
-              </a:rPr>
-              <a:t>Выбираются актуальные и разнообразные темы.</a:t>
-            </a:r>
-          </a:p>
-        </p:txBody>
-      </p:sp>
-      <p:sp>
-        <p:nvSpPr>
-          <p:cNvPr id="9" name="TextBox 8"/>
-          <p:cNvSpPr txBox="1"/>
-          <p:nvPr/>
-        </p:nvSpPr>
-        <p:spPr>
-          <a:xfrm>
-            <a:off x="6300216" y="1783080"/>
-            <a:ext cx="5394960" cy="1371600"/>
-          </a:xfrm>
-          <a:prstGeom prst="rect">
-            <a:avLst/>
-          </a:prstGeom>
-          <a:noFill/>
-        </p:spPr>
-        <p:txBody>
-          <a:bodyPr wrap="square" lIns="18288" rIns="18288" tIns="0" bIns="0" anchor="t"/>
-          <a:lstStyle/>
-          <a:p>
-            <a:pPr algn="l">
-              <a:lnSpc>
-                <a:spcPct val="105000"/>
-              </a:lnSpc>
-              <a:spcAft>
-                <a:spcPts val="200"/>
-              </a:spcAft>
-            </a:pPr>
-            <a:r>
-              <a:rPr sz="2000" b="1" i="0" lang="ru-RU" dirty="0">
-                <a:solidFill>
-                  <a:srgbClr val="1F4E79"/>
-                </a:solidFill>
-                <a:latin typeface="Arial"/>
-                <a:cs typeface="Arial"/>
-                <a:ea typeface="Arial"/>
-              </a:rPr>
-              <a:t>4. Определить форматы и тематику.</a:t>
-            </a:r>
-          </a:p>
-          <a:p>
-            <a:pPr algn="l">
-              <a:lnSpc>
-                <a:spcPct val="105000"/>
-              </a:lnSpc>
-              <a:spcAft>
-                <a:spcPts val="0"/>
-              </a:spcAft>
-            </a:pPr>
-            <a:r>
-              <a:rPr sz="1600" b="0" i="0" lang="ru-RU" dirty="0">
-                <a:solidFill>
-                  <a:srgbClr val="2D2D2D"/>
-                </a:solidFill>
-                <a:latin typeface="Arial"/>
-                <a:cs typeface="Arial"/>
-                <a:ea typeface="Arial"/>
-              </a:rPr>
-              <a:t>Где опубликовать и о чём писать.</a:t>
-            </a:r>
-          </a:p>
-        </p:txBody>
-      </p:sp>
-      <p:sp>
-        <p:nvSpPr>
-          <p:cNvPr id="10" name="TextBox 9"/>
-          <p:cNvSpPr txBox="1"/>
-          <p:nvPr/>
-        </p:nvSpPr>
-        <p:spPr>
-          <a:xfrm>
-            <a:off x="6300216" y="3291839"/>
-            <a:ext cx="5394960" cy="1371600"/>
-          </a:xfrm>
-          <a:prstGeom prst="rect">
-            <a:avLst/>
-          </a:prstGeom>
-          <a:noFill/>
-        </p:spPr>
-        <p:txBody>
-          <a:bodyPr wrap="square" lIns="18288" rIns="18288" tIns="0" bIns="0" anchor="t"/>
-          <a:lstStyle/>
-          <a:p>
-            <a:pPr algn="l">
-              <a:lnSpc>
-                <a:spcPct val="105000"/>
-              </a:lnSpc>
-              <a:spcAft>
-                <a:spcPts val="200"/>
-              </a:spcAft>
-            </a:pPr>
-            <a:r>
-              <a:rPr sz="2000" b="1" i="0" lang="ru-RU" dirty="0">
-                <a:solidFill>
-                  <a:srgbClr val="1F4E79"/>
-                </a:solidFill>
-                <a:latin typeface="Arial"/>
-                <a:cs typeface="Arial"/>
-                <a:ea typeface="Arial"/>
-              </a:rPr>
-              <a:t>5. Подобрать дату публикации.</a:t>
-            </a:r>
-          </a:p>
-        </p:txBody>
-      </p:sp>
-      <p:sp>
-        <p:nvSpPr>
-          <p:cNvPr id="11" name="TextBox 10"/>
-          <p:cNvSpPr txBox="1"/>
-          <p:nvPr/>
-        </p:nvSpPr>
-        <p:spPr>
-          <a:xfrm>
-            <a:off x="6300216" y="4800600"/>
-            <a:ext cx="5394960" cy="1371600"/>
-          </a:xfrm>
-          <a:prstGeom prst="rect">
-            <a:avLst/>
-          </a:prstGeom>
-          <a:noFill/>
-        </p:spPr>
-        <p:txBody>
-          <a:bodyPr wrap="square" lIns="18288" rIns="18288" tIns="0" bIns="0" anchor="t"/>
-          <a:lstStyle/>
-          <a:p>
-            <a:pPr algn="l">
-              <a:lnSpc>
-                <a:spcPct val="105000"/>
-              </a:lnSpc>
-              <a:spcAft>
-                <a:spcPts val="200"/>
-              </a:spcAft>
-            </a:pPr>
-            <a:r>
-              <a:rPr sz="2000" b="1" i="0" lang="ru-RU" dirty="0">
-                <a:solidFill>
-                  <a:srgbClr val="1F4E79"/>
-                </a:solidFill>
-                <a:latin typeface="Arial"/>
-                <a:cs typeface="Arial"/>
-                <a:ea typeface="Arial"/>
-              </a:rPr>
-              <a:t>6. Назначить ответственных.</a:t>
-            </a:r>
-          </a:p>
-          <a:p>
-            <a:pPr algn="l">
-              <a:lnSpc>
-                <a:spcPct val="105000"/>
-              </a:lnSpc>
-              <a:spcAft>
-                <a:spcPts val="0"/>
-              </a:spcAft>
-            </a:pPr>
-            <a:r>
-              <a:rPr sz="1600" b="0" i="0" lang="ru-RU" dirty="0">
-                <a:solidFill>
-                  <a:srgbClr val="2D2D2D"/>
-                </a:solidFill>
-                <a:latin typeface="Arial"/>
-                <a:cs typeface="Arial"/>
-                <a:ea typeface="Arial"/>
-              </a:rPr>
-              <a:t>Если над проектом работает несколько человек, каждому распределяются задачи.</a:t>
-            </a:r>
-          </a:p>
-        </p:txBody>
-      </p:sp>
-      <p:sp>
-        <p:nvSpPr>
-          <p:cNvPr id="12" name="TextBox 11"/>
-          <p:cNvSpPr txBox="1"/>
-          <p:nvPr/>
-        </p:nvSpPr>
-        <p:spPr>
-          <a:xfrm>
-            <a:off x="10607040" y="6473952"/>
-            <a:ext cx="1097280" cy="292608"/>
-          </a:xfrm>
-          <a:prstGeom prst="rect">
-            <a:avLst/>
-          </a:prstGeom>
-          <a:noFill/>
-        </p:spPr>
-        <p:txBody>
-          <a:bodyPr wrap="square" lIns="18288" rIns="18288" tIns="0" bIns="0" anchor="t"/>
-          <a:lstStyle/>
-          <a:p>
-            <a:pPr algn="r">
-              <a:lnSpc>
-                <a:spcPct val="105000"/>
-              </a:lnSpc>
-              <a:spcAft>
-                <a:spcPts val="0"/>
-              </a:spcAft>
-            </a:pPr>
-            <a:r>
-              <a:rPr sz="1400" b="0" i="0" lang="ru-RU" dirty="0">
-                <a:solidFill>
-                  <a:srgbClr val="555555"/>
-                </a:solidFill>
-                <a:latin typeface="Arial"/>
-                <a:cs typeface="Arial"/>
-                <a:ea typeface="Arial"/>
-              </a:rPr>
-              <a:t>2</a:t>
-            </a:r>
-          </a:p>
-        </p:txBody>
-      </p:sp>
+      </p:pic>
     </p:spTree>
   </p:cSld>
   <p:clrMapOvr>
@@ -3930,446 +3176,30 @@
         <p:nvPr/>
       </p:nvGrpSpPr>
       <p:grpSpPr/>
-      <p:sp>
-        <p:nvSpPr>
-          <p:cNvPr id="2" name="Rectangle 1"/>
-          <p:cNvSpPr/>
+      <p:pic>
+        <p:nvPicPr>
+          <p:cNvPr id="2" name="Picture 1" descr="03.png"/>
+          <p:cNvPicPr>
+            <a:picLocks noChangeAspect="1"/>
+          </p:cNvPicPr>
           <p:nvPr/>
-        </p:nvSpPr>
+        </p:nvPicPr>
+        <p:blipFill>
+          <a:blip r:embed="rId2"/>
+          <a:stretch>
+            <a:fillRect/>
+          </a:stretch>
+        </p:blipFill>
         <p:spPr>
           <a:xfrm>
             <a:off x="0" y="0"/>
-            <a:ext cx="12191695" cy="109728"/>
+            <a:ext cx="12191695" cy="6858000"/>
           </a:xfrm>
           <a:prstGeom prst="rect">
             <a:avLst/>
           </a:prstGeom>
-          <a:solidFill>
-            <a:srgbClr val="2E75B6"/>
-          </a:solidFill>
-          <a:ln>
-            <a:noFill/>
-          </a:ln>
         </p:spPr>
-        <p:style>
-          <a:lnRef idx="1">
-            <a:schemeClr val="accent1"/>
-          </a:lnRef>
-          <a:fillRef idx="3">
-            <a:schemeClr val="accent1"/>
-          </a:fillRef>
-          <a:effectRef idx="2">
-            <a:schemeClr val="accent1"/>
-          </a:effectRef>
-          <a:fontRef idx="minor">
-            <a:schemeClr val="lt1"/>
-          </a:fontRef>
-        </p:style>
-        <p:txBody>
-          <a:bodyPr rtlCol="0" anchor="ctr"/>
-          <a:lstStyle/>
-          <a:p>
-            <a:pPr algn="ctr"/>
-          </a:p>
-        </p:txBody>
-      </p:sp>
-      <p:sp>
-        <p:nvSpPr>
-          <p:cNvPr id="3" name="TextBox 2"/>
-          <p:cNvSpPr txBox="1"/>
-          <p:nvPr/>
-        </p:nvSpPr>
-        <p:spPr>
-          <a:xfrm>
-            <a:off x="566928" y="292608"/>
-            <a:ext cx="11064240" cy="713232"/>
-          </a:xfrm>
-          <a:prstGeom prst="rect">
-            <a:avLst/>
-          </a:prstGeom>
-          <a:noFill/>
-        </p:spPr>
-        <p:txBody>
-          <a:bodyPr wrap="square" lIns="18288" rIns="18288" tIns="0" bIns="0" anchor="t"/>
-          <a:lstStyle/>
-          <a:p>
-            <a:pPr algn="l">
-              <a:lnSpc>
-                <a:spcPct val="105000"/>
-              </a:lnSpc>
-              <a:spcAft>
-                <a:spcPts val="0"/>
-              </a:spcAft>
-            </a:pPr>
-            <a:r>
-              <a:rPr sz="3200" b="1" i="0" lang="ru-RU" dirty="0">
-                <a:solidFill>
-                  <a:srgbClr val="1F4E79"/>
-                </a:solidFill>
-                <a:latin typeface="Arial"/>
-                <a:cs typeface="Arial"/>
-                <a:ea typeface="Arial"/>
-              </a:rPr>
-              <a:t>Как выбираются темы?</a:t>
-            </a:r>
-          </a:p>
-        </p:txBody>
-      </p:sp>
-      <p:sp>
-        <p:nvSpPr>
-          <p:cNvPr id="4" name="Rectangle 3"/>
-          <p:cNvSpPr/>
-          <p:nvPr/>
-        </p:nvSpPr>
-        <p:spPr>
-          <a:xfrm>
-            <a:off x="585216" y="1060704"/>
-            <a:ext cx="2834640" cy="32004"/>
-          </a:xfrm>
-          <a:prstGeom prst="rect">
-            <a:avLst/>
-          </a:prstGeom>
-          <a:solidFill>
-            <a:srgbClr val="5B9BD5"/>
-          </a:solidFill>
-          <a:ln>
-            <a:noFill/>
-          </a:ln>
-        </p:spPr>
-        <p:style>
-          <a:lnRef idx="1">
-            <a:schemeClr val="accent1"/>
-          </a:lnRef>
-          <a:fillRef idx="3">
-            <a:schemeClr val="accent1"/>
-          </a:fillRef>
-          <a:effectRef idx="2">
-            <a:schemeClr val="accent1"/>
-          </a:effectRef>
-          <a:fontRef idx="minor">
-            <a:schemeClr val="lt1"/>
-          </a:fontRef>
-        </p:style>
-        <p:txBody>
-          <a:bodyPr rtlCol="0" anchor="ctr"/>
-          <a:lstStyle/>
-          <a:p>
-            <a:pPr algn="ctr"/>
-          </a:p>
-        </p:txBody>
-      </p:sp>
-      <p:sp>
-        <p:nvSpPr>
-          <p:cNvPr id="5" name="TextBox 4"/>
-          <p:cNvSpPr txBox="1"/>
-          <p:nvPr/>
-        </p:nvSpPr>
-        <p:spPr>
-          <a:xfrm>
-            <a:off x="585216" y="1325880"/>
-            <a:ext cx="10972800" cy="411480"/>
-          </a:xfrm>
-          <a:prstGeom prst="rect">
-            <a:avLst/>
-          </a:prstGeom>
-          <a:noFill/>
-        </p:spPr>
-        <p:txBody>
-          <a:bodyPr wrap="square" lIns="18288" rIns="18288" tIns="0" bIns="0" anchor="t"/>
-          <a:lstStyle/>
-          <a:p>
-            <a:pPr algn="l">
-              <a:lnSpc>
-                <a:spcPct val="105000"/>
-              </a:lnSpc>
-              <a:spcAft>
-                <a:spcPts val="0"/>
-              </a:spcAft>
-            </a:pPr>
-            <a:r>
-              <a:rPr sz="2000" b="0" i="0" lang="ru-RU" dirty="0">
-                <a:solidFill>
-                  <a:srgbClr val="2D2D2D"/>
-                </a:solidFill>
-                <a:latin typeface="Arial"/>
-                <a:cs typeface="Arial"/>
-                <a:ea typeface="Arial"/>
-              </a:rPr>
-              <a:t>Темы для журналистских материалов могут быть связаны с:</a:t>
-            </a:r>
-          </a:p>
-        </p:txBody>
-      </p:sp>
-      <p:sp>
-        <p:nvSpPr>
-          <p:cNvPr id="6" name="TextBox 5"/>
-          <p:cNvSpPr txBox="1"/>
-          <p:nvPr/>
-        </p:nvSpPr>
-        <p:spPr>
-          <a:xfrm>
-            <a:off x="731520" y="1874519"/>
-            <a:ext cx="4846320" cy="2377440"/>
-          </a:xfrm>
-          <a:prstGeom prst="rect">
-            <a:avLst/>
-          </a:prstGeom>
-          <a:noFill/>
-        </p:spPr>
-        <p:txBody>
-          <a:bodyPr wrap="square" lIns="18288" rIns="18288" tIns="0" bIns="0" anchor="t"/>
-          <a:lstStyle/>
-          <a:p>
-            <a:pPr algn="l">
-              <a:lnSpc>
-                <a:spcPct val="105000"/>
-              </a:lnSpc>
-              <a:spcBef>
-                <a:spcPts val="800"/>
-              </a:spcBef>
-              <a:spcAft>
-                <a:spcPts val="400"/>
-              </a:spcAft>
-            </a:pPr>
-            <a:r>
-              <a:rPr sz="2200" b="0" i="0" lang="ru-RU" dirty="0">
-                <a:solidFill>
-                  <a:srgbClr val="2D2D2D"/>
-                </a:solidFill>
-                <a:latin typeface="Arial"/>
-                <a:cs typeface="Arial"/>
-                <a:ea typeface="Arial"/>
-              </a:rPr>
-              <a:t>•  новостями</a:t>
-            </a:r>
-          </a:p>
-          <a:p>
-            <a:pPr algn="l">
-              <a:lnSpc>
-                <a:spcPct val="105000"/>
-              </a:lnSpc>
-              <a:spcBef>
-                <a:spcPts val="800"/>
-              </a:spcBef>
-              <a:spcAft>
-                <a:spcPts val="400"/>
-              </a:spcAft>
-            </a:pPr>
-            <a:r>
-              <a:rPr sz="2200" b="0" i="0" lang="ru-RU" dirty="0">
-                <a:solidFill>
-                  <a:srgbClr val="2D2D2D"/>
-                </a:solidFill>
-                <a:latin typeface="Arial"/>
-                <a:cs typeface="Arial"/>
-                <a:ea typeface="Arial"/>
-              </a:rPr>
-              <a:t>•  актуальными событиями</a:t>
-            </a:r>
-          </a:p>
-          <a:p>
-            <a:pPr algn="l">
-              <a:lnSpc>
-                <a:spcPct val="105000"/>
-              </a:lnSpc>
-              <a:spcBef>
-                <a:spcPts val="800"/>
-              </a:spcBef>
-              <a:spcAft>
-                <a:spcPts val="400"/>
-              </a:spcAft>
-            </a:pPr>
-            <a:r>
-              <a:rPr sz="2200" b="0" i="0" lang="ru-RU" dirty="0">
-                <a:solidFill>
-                  <a:srgbClr val="2D2D2D"/>
-                </a:solidFill>
-                <a:latin typeface="Arial"/>
-                <a:cs typeface="Arial"/>
-                <a:ea typeface="Arial"/>
-              </a:rPr>
-              <a:t>•  культурой и образованием</a:t>
-            </a:r>
-          </a:p>
-        </p:txBody>
-      </p:sp>
-      <p:sp>
-        <p:nvSpPr>
-          <p:cNvPr id="7" name="TextBox 6"/>
-          <p:cNvSpPr txBox="1"/>
-          <p:nvPr/>
-        </p:nvSpPr>
-        <p:spPr>
-          <a:xfrm>
-            <a:off x="5852159" y="1874519"/>
-            <a:ext cx="4846320" cy="2377440"/>
-          </a:xfrm>
-          <a:prstGeom prst="rect">
-            <a:avLst/>
-          </a:prstGeom>
-          <a:noFill/>
-        </p:spPr>
-        <p:txBody>
-          <a:bodyPr wrap="square" lIns="18288" rIns="18288" tIns="0" bIns="0" anchor="t"/>
-          <a:lstStyle/>
-          <a:p>
-            <a:pPr algn="l">
-              <a:lnSpc>
-                <a:spcPct val="105000"/>
-              </a:lnSpc>
-              <a:spcBef>
-                <a:spcPts val="800"/>
-              </a:spcBef>
-              <a:spcAft>
-                <a:spcPts val="400"/>
-              </a:spcAft>
-            </a:pPr>
-            <a:r>
-              <a:rPr sz="2200" b="0" i="0" lang="ru-RU" dirty="0">
-                <a:solidFill>
-                  <a:srgbClr val="2D2D2D"/>
-                </a:solidFill>
-                <a:latin typeface="Arial"/>
-                <a:cs typeface="Arial"/>
-                <a:ea typeface="Arial"/>
-              </a:rPr>
-              <a:t>•  спортом</a:t>
-            </a:r>
-          </a:p>
-          <a:p>
-            <a:pPr algn="l">
-              <a:lnSpc>
-                <a:spcPct val="105000"/>
-              </a:lnSpc>
-              <a:spcBef>
-                <a:spcPts val="800"/>
-              </a:spcBef>
-              <a:spcAft>
-                <a:spcPts val="400"/>
-              </a:spcAft>
-            </a:pPr>
-            <a:r>
-              <a:rPr sz="2200" b="0" i="0" lang="ru-RU" dirty="0">
-                <a:solidFill>
-                  <a:srgbClr val="2D2D2D"/>
-                </a:solidFill>
-                <a:latin typeface="Arial"/>
-                <a:cs typeface="Arial"/>
-                <a:ea typeface="Arial"/>
-              </a:rPr>
-              <a:t>•  известными личностями</a:t>
-            </a:r>
-          </a:p>
-          <a:p>
-            <a:pPr algn="l">
-              <a:lnSpc>
-                <a:spcPct val="105000"/>
-              </a:lnSpc>
-              <a:spcBef>
-                <a:spcPts val="800"/>
-              </a:spcBef>
-              <a:spcAft>
-                <a:spcPts val="400"/>
-              </a:spcAft>
-            </a:pPr>
-            <a:r>
-              <a:rPr sz="2200" b="0" i="0" lang="ru-RU" dirty="0">
-                <a:solidFill>
-                  <a:srgbClr val="2D2D2D"/>
-                </a:solidFill>
-                <a:latin typeface="Arial"/>
-                <a:cs typeface="Arial"/>
-                <a:ea typeface="Arial"/>
-              </a:rPr>
-              <a:t>•  местными событиями</a:t>
-            </a:r>
-          </a:p>
-        </p:txBody>
-      </p:sp>
-      <p:sp>
-        <p:nvSpPr>
-          <p:cNvPr id="8" name="TextBox 7"/>
-          <p:cNvSpPr txBox="1"/>
-          <p:nvPr/>
-        </p:nvSpPr>
-        <p:spPr>
-          <a:xfrm>
-            <a:off x="585216" y="4709160"/>
-            <a:ext cx="10972800" cy="1371600"/>
-          </a:xfrm>
-          <a:prstGeom prst="rect">
-            <a:avLst/>
-          </a:prstGeom>
-          <a:noFill/>
-        </p:spPr>
-        <p:txBody>
-          <a:bodyPr wrap="square" lIns="18288" rIns="18288" tIns="0" bIns="0" anchor="t"/>
-          <a:lstStyle/>
-          <a:p>
-            <a:pPr algn="l">
-              <a:lnSpc>
-                <a:spcPct val="112000"/>
-              </a:lnSpc>
-              <a:spcAft>
-                <a:spcPts val="0"/>
-              </a:spcAft>
-            </a:pPr>
-            <a:r>
-              <a:rPr sz="2000" b="0" i="0" lang="ru-RU" dirty="0">
-                <a:solidFill>
-                  <a:srgbClr val="2D2D2D"/>
-                </a:solidFill>
-                <a:latin typeface="Arial"/>
-                <a:cs typeface="Arial"/>
-                <a:ea typeface="Arial"/>
-              </a:rPr>
-              <a:t>При выборе темы важно учитывать её актуальность, общественную значимость и интерес для аудитории.</a:t>
-            </a:r>
-          </a:p>
-        </p:txBody>
-      </p:sp>
-      <p:sp>
-        <p:nvSpPr>
-          <p:cNvPr id="9" name="TextBox 8"/>
-          <p:cNvSpPr txBox="1"/>
-          <p:nvPr/>
-        </p:nvSpPr>
-        <p:spPr>
-          <a:xfrm>
-            <a:off x="10607040" y="6473952"/>
-            <a:ext cx="1097280" cy="292608"/>
-          </a:xfrm>
-          <a:prstGeom prst="rect">
-            <a:avLst/>
-          </a:prstGeom>
-          <a:noFill/>
-        </p:spPr>
-        <p:txBody>
-          <a:bodyPr wrap="square" lIns="18288" rIns="18288" tIns="0" bIns="0" anchor="t"/>
-          <a:lstStyle/>
-          <a:p>
-            <a:pPr algn="r">
-              <a:lnSpc>
-                <a:spcPct val="105000"/>
-              </a:lnSpc>
-              <a:spcAft>
-                <a:spcPts val="0"/>
-              </a:spcAft>
-            </a:pPr>
-            <a:r>
-              <a:rPr sz="1400" b="0" i="0" lang="ru-RU" dirty="0">
-                <a:solidFill>
-                  <a:srgbClr val="555555"/>
-                </a:solidFill>
-                <a:latin typeface="Arial"/>
-                <a:cs typeface="Arial"/>
-                <a:ea typeface="Arial"/>
-              </a:rPr>
-              <a:t>3</a:t>
-            </a:r>
-          </a:p>
-        </p:txBody>
-      </p:sp>
+      </p:pic>
     </p:spTree>
   </p:cSld>
   <p:clrMapOvr>
@@ -4388,693 +3218,30 @@
         <p:nvPr/>
       </p:nvGrpSpPr>
       <p:grpSpPr/>
-      <p:sp>
-        <p:nvSpPr>
-          <p:cNvPr id="2" name="Rectangle 1"/>
-          <p:cNvSpPr/>
+      <p:pic>
+        <p:nvPicPr>
+          <p:cNvPr id="2" name="Picture 1" descr="04.png"/>
+          <p:cNvPicPr>
+            <a:picLocks noChangeAspect="1"/>
+          </p:cNvPicPr>
           <p:nvPr/>
-        </p:nvSpPr>
+        </p:nvPicPr>
+        <p:blipFill>
+          <a:blip r:embed="rId2"/>
+          <a:stretch>
+            <a:fillRect/>
+          </a:stretch>
+        </p:blipFill>
         <p:spPr>
           <a:xfrm>
             <a:off x="0" y="0"/>
-            <a:ext cx="12191695" cy="109728"/>
+            <a:ext cx="12191695" cy="6858000"/>
           </a:xfrm>
           <a:prstGeom prst="rect">
             <a:avLst/>
           </a:prstGeom>
-          <a:solidFill>
-            <a:srgbClr val="2E75B6"/>
-          </a:solidFill>
-          <a:ln>
-            <a:noFill/>
-          </a:ln>
         </p:spPr>
-        <p:style>
-          <a:lnRef idx="1">
-            <a:schemeClr val="accent1"/>
-          </a:lnRef>
-          <a:fillRef idx="3">
-            <a:schemeClr val="accent1"/>
-          </a:fillRef>
-          <a:effectRef idx="2">
-            <a:schemeClr val="accent1"/>
-          </a:effectRef>
-          <a:fontRef idx="minor">
-            <a:schemeClr val="lt1"/>
-          </a:fontRef>
-        </p:style>
-        <p:txBody>
-          <a:bodyPr rtlCol="0" anchor="ctr"/>
-          <a:lstStyle/>
-          <a:p>
-            <a:pPr algn="ctr"/>
-          </a:p>
-        </p:txBody>
-      </p:sp>
-      <p:sp>
-        <p:nvSpPr>
-          <p:cNvPr id="3" name="TextBox 2"/>
-          <p:cNvSpPr txBox="1"/>
-          <p:nvPr/>
-        </p:nvSpPr>
-        <p:spPr>
-          <a:xfrm>
-            <a:off x="566928" y="292608"/>
-            <a:ext cx="11064240" cy="713232"/>
-          </a:xfrm>
-          <a:prstGeom prst="rect">
-            <a:avLst/>
-          </a:prstGeom>
-          <a:noFill/>
-        </p:spPr>
-        <p:txBody>
-          <a:bodyPr wrap="square" lIns="18288" rIns="18288" tIns="0" bIns="0" anchor="t"/>
-          <a:lstStyle/>
-          <a:p>
-            <a:pPr algn="l">
-              <a:lnSpc>
-                <a:spcPct val="105000"/>
-              </a:lnSpc>
-              <a:spcAft>
-                <a:spcPts val="0"/>
-              </a:spcAft>
-            </a:pPr>
-            <a:r>
-              <a:rPr sz="3200" b="1" i="0" lang="ru-RU" dirty="0">
-                <a:solidFill>
-                  <a:srgbClr val="1F4E79"/>
-                </a:solidFill>
-                <a:latin typeface="Arial"/>
-                <a:cs typeface="Arial"/>
-                <a:ea typeface="Arial"/>
-              </a:rPr>
-              <a:t>Что учитывать при создании контент-плана?</a:t>
-            </a:r>
-          </a:p>
-        </p:txBody>
-      </p:sp>
-      <p:sp>
-        <p:nvSpPr>
-          <p:cNvPr id="4" name="Rectangle 3"/>
-          <p:cNvSpPr/>
-          <p:nvPr/>
-        </p:nvSpPr>
-        <p:spPr>
-          <a:xfrm>
-            <a:off x="585216" y="1060704"/>
-            <a:ext cx="2834640" cy="32004"/>
-          </a:xfrm>
-          <a:prstGeom prst="rect">
-            <a:avLst/>
-          </a:prstGeom>
-          <a:solidFill>
-            <a:srgbClr val="5B9BD5"/>
-          </a:solidFill>
-          <a:ln>
-            <a:noFill/>
-          </a:ln>
-        </p:spPr>
-        <p:style>
-          <a:lnRef idx="1">
-            <a:schemeClr val="accent1"/>
-          </a:lnRef>
-          <a:fillRef idx="3">
-            <a:schemeClr val="accent1"/>
-          </a:fillRef>
-          <a:effectRef idx="2">
-            <a:schemeClr val="accent1"/>
-          </a:effectRef>
-          <a:fontRef idx="minor">
-            <a:schemeClr val="lt1"/>
-          </a:fontRef>
-        </p:style>
-        <p:txBody>
-          <a:bodyPr rtlCol="0" anchor="ctr"/>
-          <a:lstStyle/>
-          <a:p>
-            <a:pPr algn="ctr"/>
-          </a:p>
-        </p:txBody>
-      </p:sp>
-      <p:sp>
-        <p:nvSpPr>
-          <p:cNvPr id="5" name="TextBox 4"/>
-          <p:cNvSpPr txBox="1"/>
-          <p:nvPr/>
-        </p:nvSpPr>
-        <p:spPr>
-          <a:xfrm>
-            <a:off x="585216" y="1298448"/>
-            <a:ext cx="10972800" cy="384048"/>
-          </a:xfrm>
-          <a:prstGeom prst="rect">
-            <a:avLst/>
-          </a:prstGeom>
-          <a:noFill/>
-        </p:spPr>
-        <p:txBody>
-          <a:bodyPr wrap="square" lIns="18288" rIns="18288" tIns="0" bIns="0" anchor="t"/>
-          <a:lstStyle/>
-          <a:p>
-            <a:pPr algn="l">
-              <a:lnSpc>
-                <a:spcPct val="105000"/>
-              </a:lnSpc>
-              <a:spcAft>
-                <a:spcPts val="0"/>
-              </a:spcAft>
-            </a:pPr>
-            <a:r>
-              <a:rPr sz="2000" b="0" i="0" lang="ru-RU" dirty="0">
-                <a:solidFill>
-                  <a:srgbClr val="2D2D2D"/>
-                </a:solidFill>
-                <a:latin typeface="Arial"/>
-                <a:cs typeface="Arial"/>
-                <a:ea typeface="Arial"/>
-              </a:rPr>
-              <a:t>Хороший контент-план должен быть:</a:t>
-            </a:r>
-          </a:p>
-        </p:txBody>
-      </p:sp>
-      <p:sp>
-        <p:nvSpPr>
-          <p:cNvPr id="6" name="Rectangle 5"/>
-          <p:cNvSpPr/>
-          <p:nvPr/>
-        </p:nvSpPr>
-        <p:spPr>
-          <a:xfrm>
-            <a:off x="640080" y="1938528"/>
-            <a:ext cx="128016" cy="128016"/>
-          </a:xfrm>
-          <a:prstGeom prst="rect">
-            <a:avLst/>
-          </a:prstGeom>
-          <a:solidFill>
-            <a:srgbClr val="2E75B6"/>
-          </a:solidFill>
-          <a:ln>
-            <a:noFill/>
-          </a:ln>
-        </p:spPr>
-        <p:style>
-          <a:lnRef idx="1">
-            <a:schemeClr val="accent1"/>
-          </a:lnRef>
-          <a:fillRef idx="3">
-            <a:schemeClr val="accent1"/>
-          </a:fillRef>
-          <a:effectRef idx="2">
-            <a:schemeClr val="accent1"/>
-          </a:effectRef>
-          <a:fontRef idx="minor">
-            <a:schemeClr val="lt1"/>
-          </a:fontRef>
-        </p:style>
-        <p:txBody>
-          <a:bodyPr rtlCol="0" anchor="ctr"/>
-          <a:lstStyle/>
-          <a:p>
-            <a:pPr algn="ctr"/>
-          </a:p>
-        </p:txBody>
-      </p:sp>
-      <p:sp>
-        <p:nvSpPr>
-          <p:cNvPr id="7" name="TextBox 6"/>
-          <p:cNvSpPr txBox="1"/>
-          <p:nvPr/>
-        </p:nvSpPr>
-        <p:spPr>
-          <a:xfrm>
-            <a:off x="960120" y="1828800"/>
-            <a:ext cx="10424160" cy="731520"/>
-          </a:xfrm>
-          <a:prstGeom prst="rect">
-            <a:avLst/>
-          </a:prstGeom>
-          <a:noFill/>
-        </p:spPr>
-        <p:txBody>
-          <a:bodyPr wrap="square" lIns="0" rIns="0" tIns="0">
-            <a:spAutoFit/>
-          </a:bodyPr>
-          <a:lstStyle/>
-          <a:p>
-            <a:pPr>
-              <a:spcAft>
-                <a:spcPts val="0"/>
-              </a:spcAft>
-            </a:pPr>
-            <a:r>
-              <a:rPr sz="2200" b="1" i="0" lang="ru-RU" dirty="0">
-                <a:solidFill>
-                  <a:srgbClr val="1F4E79"/>
-                </a:solidFill>
-                <a:latin typeface="Arial"/>
-                <a:cs typeface="Arial"/>
-                <a:ea typeface="Arial"/>
-              </a:rPr>
-              <a:t>актуальным</a:t>
-            </a:r>
-            <a:r>
-              <a:rPr sz="2200" b="0" i="0" lang="ru-RU" dirty="0">
-                <a:solidFill>
-                  <a:srgbClr val="2D2D2D"/>
-                </a:solidFill>
-                <a:latin typeface="Arial"/>
-                <a:cs typeface="Arial"/>
-                <a:ea typeface="Arial"/>
-              </a:rPr>
-              <a:t> — учитывать события и новости</a:t>
-            </a:r>
-          </a:p>
-        </p:txBody>
-      </p:sp>
-      <p:sp>
-        <p:nvSpPr>
-          <p:cNvPr id="8" name="Rectangle 7"/>
-          <p:cNvSpPr/>
-          <p:nvPr/>
-        </p:nvSpPr>
-        <p:spPr>
-          <a:xfrm>
-            <a:off x="640080" y="2761488"/>
-            <a:ext cx="128016" cy="128016"/>
-          </a:xfrm>
-          <a:prstGeom prst="rect">
-            <a:avLst/>
-          </a:prstGeom>
-          <a:solidFill>
-            <a:srgbClr val="2E75B6"/>
-          </a:solidFill>
-          <a:ln>
-            <a:noFill/>
-          </a:ln>
-        </p:spPr>
-        <p:style>
-          <a:lnRef idx="1">
-            <a:schemeClr val="accent1"/>
-          </a:lnRef>
-          <a:fillRef idx="3">
-            <a:schemeClr val="accent1"/>
-          </a:fillRef>
-          <a:effectRef idx="2">
-            <a:schemeClr val="accent1"/>
-          </a:effectRef>
-          <a:fontRef idx="minor">
-            <a:schemeClr val="lt1"/>
-          </a:fontRef>
-        </p:style>
-        <p:txBody>
-          <a:bodyPr rtlCol="0" anchor="ctr"/>
-          <a:lstStyle/>
-          <a:p>
-            <a:pPr algn="ctr"/>
-          </a:p>
-        </p:txBody>
-      </p:sp>
-      <p:sp>
-        <p:nvSpPr>
-          <p:cNvPr id="9" name="TextBox 8"/>
-          <p:cNvSpPr txBox="1"/>
-          <p:nvPr/>
-        </p:nvSpPr>
-        <p:spPr>
-          <a:xfrm>
-            <a:off x="960120" y="2651760"/>
-            <a:ext cx="10424160" cy="731520"/>
-          </a:xfrm>
-          <a:prstGeom prst="rect">
-            <a:avLst/>
-          </a:prstGeom>
-          <a:noFill/>
-        </p:spPr>
-        <p:txBody>
-          <a:bodyPr wrap="square" lIns="0" rIns="0" tIns="0">
-            <a:spAutoFit/>
-          </a:bodyPr>
-          <a:lstStyle/>
-          <a:p>
-            <a:pPr>
-              <a:spcAft>
-                <a:spcPts val="0"/>
-              </a:spcAft>
-            </a:pPr>
-            <a:r>
-              <a:rPr sz="2200" b="1" i="0" lang="ru-RU" dirty="0">
-                <a:solidFill>
-                  <a:srgbClr val="1F4E79"/>
-                </a:solidFill>
-                <a:latin typeface="Arial"/>
-                <a:cs typeface="Arial"/>
-                <a:ea typeface="Arial"/>
-              </a:rPr>
-              <a:t>разнообразным</a:t>
-            </a:r>
-            <a:r>
-              <a:rPr sz="2200" b="0" i="0" lang="ru-RU" dirty="0">
-                <a:solidFill>
-                  <a:srgbClr val="2D2D2D"/>
-                </a:solidFill>
-                <a:latin typeface="Arial"/>
-                <a:cs typeface="Arial"/>
-                <a:ea typeface="Arial"/>
-              </a:rPr>
-              <a:t> — включать разные темы и форматы</a:t>
-            </a:r>
-          </a:p>
-        </p:txBody>
-      </p:sp>
-      <p:sp>
-        <p:nvSpPr>
-          <p:cNvPr id="10" name="Rectangle 9"/>
-          <p:cNvSpPr/>
-          <p:nvPr/>
-        </p:nvSpPr>
-        <p:spPr>
-          <a:xfrm>
-            <a:off x="640080" y="3584448"/>
-            <a:ext cx="128016" cy="128016"/>
-          </a:xfrm>
-          <a:prstGeom prst="rect">
-            <a:avLst/>
-          </a:prstGeom>
-          <a:solidFill>
-            <a:srgbClr val="2E75B6"/>
-          </a:solidFill>
-          <a:ln>
-            <a:noFill/>
-          </a:ln>
-        </p:spPr>
-        <p:style>
-          <a:lnRef idx="1">
-            <a:schemeClr val="accent1"/>
-          </a:lnRef>
-          <a:fillRef idx="3">
-            <a:schemeClr val="accent1"/>
-          </a:fillRef>
-          <a:effectRef idx="2">
-            <a:schemeClr val="accent1"/>
-          </a:effectRef>
-          <a:fontRef idx="minor">
-            <a:schemeClr val="lt1"/>
-          </a:fontRef>
-        </p:style>
-        <p:txBody>
-          <a:bodyPr rtlCol="0" anchor="ctr"/>
-          <a:lstStyle/>
-          <a:p>
-            <a:pPr algn="ctr"/>
-          </a:p>
-        </p:txBody>
-      </p:sp>
-      <p:sp>
-        <p:nvSpPr>
-          <p:cNvPr id="11" name="TextBox 10"/>
-          <p:cNvSpPr txBox="1"/>
-          <p:nvPr/>
-        </p:nvSpPr>
-        <p:spPr>
-          <a:xfrm>
-            <a:off x="960120" y="3474720"/>
-            <a:ext cx="10424160" cy="731520"/>
-          </a:xfrm>
-          <a:prstGeom prst="rect">
-            <a:avLst/>
-          </a:prstGeom>
-          <a:noFill/>
-        </p:spPr>
-        <p:txBody>
-          <a:bodyPr wrap="square" lIns="0" rIns="0" tIns="0">
-            <a:spAutoFit/>
-          </a:bodyPr>
-          <a:lstStyle/>
-          <a:p>
-            <a:pPr>
-              <a:spcAft>
-                <a:spcPts val="0"/>
-              </a:spcAft>
-            </a:pPr>
-            <a:r>
-              <a:rPr sz="2200" b="1" i="0" lang="ru-RU" dirty="0">
-                <a:solidFill>
-                  <a:srgbClr val="1F4E79"/>
-                </a:solidFill>
-                <a:latin typeface="Arial"/>
-                <a:cs typeface="Arial"/>
-                <a:ea typeface="Arial"/>
-              </a:rPr>
-              <a:t>реалистичным</a:t>
-            </a:r>
-            <a:r>
-              <a:rPr sz="2200" b="0" i="0" lang="ru-RU" dirty="0">
-                <a:solidFill>
-                  <a:srgbClr val="2D2D2D"/>
-                </a:solidFill>
-                <a:latin typeface="Arial"/>
-                <a:cs typeface="Arial"/>
-                <a:ea typeface="Arial"/>
-              </a:rPr>
-              <a:t> — соответствовать возможностям редакции</a:t>
-            </a:r>
-          </a:p>
-        </p:txBody>
-      </p:sp>
-      <p:sp>
-        <p:nvSpPr>
-          <p:cNvPr id="12" name="Rectangle 11"/>
-          <p:cNvSpPr/>
-          <p:nvPr/>
-        </p:nvSpPr>
-        <p:spPr>
-          <a:xfrm>
-            <a:off x="640080" y="4407408"/>
-            <a:ext cx="128016" cy="128016"/>
-          </a:xfrm>
-          <a:prstGeom prst="rect">
-            <a:avLst/>
-          </a:prstGeom>
-          <a:solidFill>
-            <a:srgbClr val="2E75B6"/>
-          </a:solidFill>
-          <a:ln>
-            <a:noFill/>
-          </a:ln>
-        </p:spPr>
-        <p:style>
-          <a:lnRef idx="1">
-            <a:schemeClr val="accent1"/>
-          </a:lnRef>
-          <a:fillRef idx="3">
-            <a:schemeClr val="accent1"/>
-          </a:fillRef>
-          <a:effectRef idx="2">
-            <a:schemeClr val="accent1"/>
-          </a:effectRef>
-          <a:fontRef idx="minor">
-            <a:schemeClr val="lt1"/>
-          </a:fontRef>
-        </p:style>
-        <p:txBody>
-          <a:bodyPr rtlCol="0" anchor="ctr"/>
-          <a:lstStyle/>
-          <a:p>
-            <a:pPr algn="ctr"/>
-          </a:p>
-        </p:txBody>
-      </p:sp>
-      <p:sp>
-        <p:nvSpPr>
-          <p:cNvPr id="13" name="TextBox 12"/>
-          <p:cNvSpPr txBox="1"/>
-          <p:nvPr/>
-        </p:nvSpPr>
-        <p:spPr>
-          <a:xfrm>
-            <a:off x="960120" y="4297680"/>
-            <a:ext cx="10424160" cy="731520"/>
-          </a:xfrm>
-          <a:prstGeom prst="rect">
-            <a:avLst/>
-          </a:prstGeom>
-          <a:noFill/>
-        </p:spPr>
-        <p:txBody>
-          <a:bodyPr wrap="square" lIns="0" rIns="0" tIns="0">
-            <a:spAutoFit/>
-          </a:bodyPr>
-          <a:lstStyle/>
-          <a:p>
-            <a:pPr>
-              <a:spcAft>
-                <a:spcPts val="0"/>
-              </a:spcAft>
-            </a:pPr>
-            <a:r>
-              <a:rPr sz="2200" b="1" i="0" lang="ru-RU" dirty="0">
-                <a:solidFill>
-                  <a:srgbClr val="1F4E79"/>
-                </a:solidFill>
-                <a:latin typeface="Arial"/>
-                <a:cs typeface="Arial"/>
-                <a:ea typeface="Arial"/>
-              </a:rPr>
-              <a:t>гибким</a:t>
-            </a:r>
-            <a:r>
-              <a:rPr sz="2200" b="0" i="0" lang="ru-RU" dirty="0">
-                <a:solidFill>
-                  <a:srgbClr val="2D2D2D"/>
-                </a:solidFill>
-                <a:latin typeface="Arial"/>
-                <a:cs typeface="Arial"/>
-                <a:ea typeface="Arial"/>
-              </a:rPr>
-              <a:t> — позволять менять план при появлении важных новостей</a:t>
-            </a:r>
-          </a:p>
-        </p:txBody>
-      </p:sp>
-      <p:sp>
-        <p:nvSpPr>
-          <p:cNvPr id="14" name="Rectangle 13"/>
-          <p:cNvSpPr/>
-          <p:nvPr/>
-        </p:nvSpPr>
-        <p:spPr>
-          <a:xfrm>
-            <a:off x="640080" y="5230368"/>
-            <a:ext cx="128016" cy="128016"/>
-          </a:xfrm>
-          <a:prstGeom prst="rect">
-            <a:avLst/>
-          </a:prstGeom>
-          <a:solidFill>
-            <a:srgbClr val="2E75B6"/>
-          </a:solidFill>
-          <a:ln>
-            <a:noFill/>
-          </a:ln>
-        </p:spPr>
-        <p:style>
-          <a:lnRef idx="1">
-            <a:schemeClr val="accent1"/>
-          </a:lnRef>
-          <a:fillRef idx="3">
-            <a:schemeClr val="accent1"/>
-          </a:fillRef>
-          <a:effectRef idx="2">
-            <a:schemeClr val="accent1"/>
-          </a:effectRef>
-          <a:fontRef idx="minor">
-            <a:schemeClr val="lt1"/>
-          </a:fontRef>
-        </p:style>
-        <p:txBody>
-          <a:bodyPr rtlCol="0" anchor="ctr"/>
-          <a:lstStyle/>
-          <a:p>
-            <a:pPr algn="ctr"/>
-          </a:p>
-        </p:txBody>
-      </p:sp>
-      <p:sp>
-        <p:nvSpPr>
-          <p:cNvPr id="15" name="TextBox 14"/>
-          <p:cNvSpPr txBox="1"/>
-          <p:nvPr/>
-        </p:nvSpPr>
-        <p:spPr>
-          <a:xfrm>
-            <a:off x="960120" y="5120640"/>
-            <a:ext cx="10424160" cy="731520"/>
-          </a:xfrm>
-          <a:prstGeom prst="rect">
-            <a:avLst/>
-          </a:prstGeom>
-          <a:noFill/>
-        </p:spPr>
-        <p:txBody>
-          <a:bodyPr wrap="square" lIns="0" rIns="0" tIns="0">
-            <a:spAutoFit/>
-          </a:bodyPr>
-          <a:lstStyle/>
-          <a:p>
-            <a:pPr>
-              <a:spcAft>
-                <a:spcPts val="0"/>
-              </a:spcAft>
-            </a:pPr>
-            <a:r>
-              <a:rPr sz="2200" b="1" i="0" lang="ru-RU" dirty="0">
-                <a:solidFill>
-                  <a:srgbClr val="1F4E79"/>
-                </a:solidFill>
-                <a:latin typeface="Arial"/>
-                <a:cs typeface="Arial"/>
-                <a:ea typeface="Arial"/>
-              </a:rPr>
-              <a:t>ориентированным на аудиторию</a:t>
-            </a:r>
-            <a:r>
-              <a:rPr sz="2200" b="0" i="0" lang="ru-RU" dirty="0">
-                <a:solidFill>
-                  <a:srgbClr val="2D2D2D"/>
-                </a:solidFill>
-                <a:latin typeface="Arial"/>
-                <a:cs typeface="Arial"/>
-                <a:ea typeface="Arial"/>
-              </a:rPr>
-              <a:t> — учитывать её интересы и потребности</a:t>
-            </a:r>
-          </a:p>
-        </p:txBody>
-      </p:sp>
-      <p:sp>
-        <p:nvSpPr>
-          <p:cNvPr id="16" name="TextBox 15"/>
-          <p:cNvSpPr txBox="1"/>
-          <p:nvPr/>
-        </p:nvSpPr>
-        <p:spPr>
-          <a:xfrm>
-            <a:off x="10607040" y="6473952"/>
-            <a:ext cx="1097280" cy="292608"/>
-          </a:xfrm>
-          <a:prstGeom prst="rect">
-            <a:avLst/>
-          </a:prstGeom>
-          <a:noFill/>
-        </p:spPr>
-        <p:txBody>
-          <a:bodyPr wrap="square" lIns="18288" rIns="18288" tIns="0" bIns="0" anchor="t"/>
-          <a:lstStyle/>
-          <a:p>
-            <a:pPr algn="r">
-              <a:lnSpc>
-                <a:spcPct val="105000"/>
-              </a:lnSpc>
-              <a:spcAft>
-                <a:spcPts val="0"/>
-              </a:spcAft>
-            </a:pPr>
-            <a:r>
-              <a:rPr sz="1400" b="0" i="0" lang="ru-RU" dirty="0">
-                <a:solidFill>
-                  <a:srgbClr val="555555"/>
-                </a:solidFill>
-                <a:latin typeface="Arial"/>
-                <a:cs typeface="Arial"/>
-                <a:ea typeface="Arial"/>
-              </a:rPr>
-              <a:t>4</a:t>
-            </a:r>
-          </a:p>
-        </p:txBody>
-      </p:sp>
+      </p:pic>
     </p:spTree>
   </p:cSld>
   <p:clrMapOvr>
@@ -5093,239 +3260,30 @@
         <p:nvPr/>
       </p:nvGrpSpPr>
       <p:grpSpPr/>
-      <p:sp>
-        <p:nvSpPr>
-          <p:cNvPr id="2" name="Rectangle 1"/>
-          <p:cNvSpPr/>
+      <p:pic>
+        <p:nvPicPr>
+          <p:cNvPr id="2" name="Picture 1" descr="05.png"/>
+          <p:cNvPicPr>
+            <a:picLocks noChangeAspect="1"/>
+          </p:cNvPicPr>
           <p:nvPr/>
-        </p:nvSpPr>
+        </p:nvPicPr>
+        <p:blipFill>
+          <a:blip r:embed="rId2"/>
+          <a:stretch>
+            <a:fillRect/>
+          </a:stretch>
+        </p:blipFill>
         <p:spPr>
           <a:xfrm>
             <a:off x="0" y="0"/>
-            <a:ext cx="12191695" cy="109728"/>
+            <a:ext cx="12191695" cy="6858000"/>
           </a:xfrm>
           <a:prstGeom prst="rect">
             <a:avLst/>
           </a:prstGeom>
-          <a:solidFill>
-            <a:srgbClr val="2E75B6"/>
-          </a:solidFill>
-          <a:ln>
-            <a:noFill/>
-          </a:ln>
         </p:spPr>
-        <p:style>
-          <a:lnRef idx="1">
-            <a:schemeClr val="accent1"/>
-          </a:lnRef>
-          <a:fillRef idx="3">
-            <a:schemeClr val="accent1"/>
-          </a:fillRef>
-          <a:effectRef idx="2">
-            <a:schemeClr val="accent1"/>
-          </a:effectRef>
-          <a:fontRef idx="minor">
-            <a:schemeClr val="lt1"/>
-          </a:fontRef>
-        </p:style>
-        <p:txBody>
-          <a:bodyPr rtlCol="0" anchor="ctr"/>
-          <a:lstStyle/>
-          <a:p>
-            <a:pPr algn="ctr"/>
-          </a:p>
-        </p:txBody>
-      </p:sp>
-      <p:sp>
-        <p:nvSpPr>
-          <p:cNvPr id="3" name="TextBox 2"/>
-          <p:cNvSpPr txBox="1"/>
-          <p:nvPr/>
-        </p:nvSpPr>
-        <p:spPr>
-          <a:xfrm>
-            <a:off x="566928" y="292608"/>
-            <a:ext cx="11064240" cy="713232"/>
-          </a:xfrm>
-          <a:prstGeom prst="rect">
-            <a:avLst/>
-          </a:prstGeom>
-          <a:noFill/>
-        </p:spPr>
-        <p:txBody>
-          <a:bodyPr wrap="square" lIns="18288" rIns="18288" tIns="0" bIns="0" anchor="t"/>
-          <a:lstStyle/>
-          <a:p>
-            <a:pPr algn="l">
-              <a:lnSpc>
-                <a:spcPct val="105000"/>
-              </a:lnSpc>
-              <a:spcAft>
-                <a:spcPts val="0"/>
-              </a:spcAft>
-            </a:pPr>
-            <a:r>
-              <a:rPr sz="3200" b="1" i="0" lang="ru-RU" dirty="0">
-                <a:solidFill>
-                  <a:srgbClr val="1F4E79"/>
-                </a:solidFill>
-                <a:latin typeface="Arial"/>
-                <a:cs typeface="Arial"/>
-                <a:ea typeface="Arial"/>
-              </a:rPr>
-              <a:t>Заключение</a:t>
-            </a:r>
-          </a:p>
-        </p:txBody>
-      </p:sp>
-      <p:sp>
-        <p:nvSpPr>
-          <p:cNvPr id="4" name="Rectangle 3"/>
-          <p:cNvSpPr/>
-          <p:nvPr/>
-        </p:nvSpPr>
-        <p:spPr>
-          <a:xfrm>
-            <a:off x="585216" y="1060704"/>
-            <a:ext cx="2834640" cy="32004"/>
-          </a:xfrm>
-          <a:prstGeom prst="rect">
-            <a:avLst/>
-          </a:prstGeom>
-          <a:solidFill>
-            <a:srgbClr val="5B9BD5"/>
-          </a:solidFill>
-          <a:ln>
-            <a:noFill/>
-          </a:ln>
-        </p:spPr>
-        <p:style>
-          <a:lnRef idx="1">
-            <a:schemeClr val="accent1"/>
-          </a:lnRef>
-          <a:fillRef idx="3">
-            <a:schemeClr val="accent1"/>
-          </a:fillRef>
-          <a:effectRef idx="2">
-            <a:schemeClr val="accent1"/>
-          </a:effectRef>
-          <a:fontRef idx="minor">
-            <a:schemeClr val="lt1"/>
-          </a:fontRef>
-        </p:style>
-        <p:txBody>
-          <a:bodyPr rtlCol="0" anchor="ctr"/>
-          <a:lstStyle/>
-          <a:p>
-            <a:pPr algn="ctr"/>
-          </a:p>
-        </p:txBody>
-      </p:sp>
-      <p:sp>
-        <p:nvSpPr>
-          <p:cNvPr id="5" name="TextBox 4"/>
-          <p:cNvSpPr txBox="1"/>
-          <p:nvPr/>
-        </p:nvSpPr>
-        <p:spPr>
-          <a:xfrm>
-            <a:off x="585216" y="1554480"/>
-            <a:ext cx="10972800" cy="4023360"/>
-          </a:xfrm>
-          <a:prstGeom prst="rect">
-            <a:avLst/>
-          </a:prstGeom>
-          <a:noFill/>
-        </p:spPr>
-        <p:txBody>
-          <a:bodyPr wrap="square" lIns="18288" rIns="18288" tIns="0" bIns="0" anchor="t"/>
-          <a:lstStyle/>
-          <a:p>
-            <a:pPr algn="l">
-              <a:lnSpc>
-                <a:spcPct val="115000"/>
-              </a:lnSpc>
-              <a:spcAft>
-                <a:spcPts val="1400"/>
-              </a:spcAft>
-            </a:pPr>
-            <a:r>
-              <a:rPr sz="2200" b="0" i="0" lang="ru-RU" dirty="0">
-                <a:solidFill>
-                  <a:srgbClr val="2D2D2D"/>
-                </a:solidFill>
-                <a:latin typeface="Arial"/>
-                <a:cs typeface="Arial"/>
-                <a:ea typeface="Arial"/>
-              </a:rPr>
-              <a:t>Контент-план позволяет заранее определить темы, форматы, сроки и площадки для публикаций.</a:t>
-            </a:r>
-          </a:p>
-          <a:p>
-            <a:pPr algn="l">
-              <a:lnSpc>
-                <a:spcPct val="115000"/>
-              </a:lnSpc>
-              <a:spcAft>
-                <a:spcPts val="0"/>
-              </a:spcAft>
-            </a:pPr>
-            <a:r>
-              <a:rPr sz="2200" b="0" i="0" lang="ru-RU" dirty="0">
-                <a:solidFill>
-                  <a:srgbClr val="2D2D2D"/>
-                </a:solidFill>
-                <a:latin typeface="Arial"/>
-                <a:cs typeface="Arial"/>
-                <a:ea typeface="Arial"/>
-              </a:rPr>
-              <a:t>Но действительно хороший контент-план должен сочетать структуру, разнообразие и гибкость. Поэтому он так важен в работе.</a:t>
-            </a:r>
-          </a:p>
-        </p:txBody>
-      </p:sp>
-      <p:sp>
-        <p:nvSpPr>
-          <p:cNvPr id="6" name="TextBox 5"/>
-          <p:cNvSpPr txBox="1"/>
-          <p:nvPr/>
-        </p:nvSpPr>
-        <p:spPr>
-          <a:xfrm>
-            <a:off x="10607040" y="6473952"/>
-            <a:ext cx="1097280" cy="292608"/>
-          </a:xfrm>
-          <a:prstGeom prst="rect">
-            <a:avLst/>
-          </a:prstGeom>
-          <a:noFill/>
-        </p:spPr>
-        <p:txBody>
-          <a:bodyPr wrap="square" lIns="18288" rIns="18288" tIns="0" bIns="0" anchor="t"/>
-          <a:lstStyle/>
-          <a:p>
-            <a:pPr algn="r">
-              <a:lnSpc>
-                <a:spcPct val="105000"/>
-              </a:lnSpc>
-              <a:spcAft>
-                <a:spcPts val="0"/>
-              </a:spcAft>
-            </a:pPr>
-            <a:r>
-              <a:rPr sz="1400" b="0" i="0" lang="ru-RU" dirty="0">
-                <a:solidFill>
-                  <a:srgbClr val="555555"/>
-                </a:solidFill>
-                <a:latin typeface="Arial"/>
-                <a:cs typeface="Arial"/>
-                <a:ea typeface="Arial"/>
-              </a:rPr>
-              <a:t>5</a:t>
-            </a:r>
-          </a:p>
-        </p:txBody>
-      </p:sp>
+      </p:pic>
     </p:spTree>
   </p:cSld>
   <p:clrMapOvr>

</xml_diff>